<commit_message>
(docs): diagrams — update architecture diagrams and add round-trip diagram
</commit_message>
<xml_diff>
--- a/diagrams/openaos-overview-for-collaborators.pptx
+++ b/diagrams/openaos-overview-for-collaborators.pptx
@@ -5,7 +5,7 @@
     <p:sldMasterId id="2147483648" r:id="rId1"/>
   </p:sldMasterIdLst>
   <p:notesMasterIdLst>
-    <p:notesMasterId r:id="rId11"/>
+    <p:notesMasterId r:id="rId12"/>
   </p:notesMasterIdLst>
   <p:sldIdLst>
     <p:sldId id="256" r:id="rId2"/>
@@ -16,7 +16,8 @@
     <p:sldId id="261" r:id="rId7"/>
     <p:sldId id="264" r:id="rId8"/>
     <p:sldId id="262" r:id="rId9"/>
-    <p:sldId id="263" r:id="rId10"/>
+    <p:sldId id="265" r:id="rId10"/>
+    <p:sldId id="263" r:id="rId11"/>
   </p:sldIdLst>
   <p:sldSz cx="12192000" cy="6858000"/>
   <p:notesSz cx="7315200" cy="9601200"/>
@@ -216,7 +217,7 @@
           <a:p>
             <a:fld id="{26272460-AD5D-4C37-9540-968E0C435ACB}" type="datetimeFigureOut">
               <a:rPr lang="en-US" smtClean="0"/>
-              <a:t>8/4/2026</a:t>
+              <a:t>8/5/2026</a:t>
             </a:fld>
             <a:endParaRPr lang="en-US"/>
           </a:p>
@@ -598,6 +599,92 @@
 </p:notes>
 </file>
 
+<file path=ppt/notesSlides/notesSlide10.xml><?xml version="1.0" encoding="utf-8"?>
+<p:notes xmlns:a="http://schemas.openxmlformats.org/drawingml/2006/main" xmlns:r="http://schemas.openxmlformats.org/officeDocument/2006/relationships" xmlns:p="http://schemas.openxmlformats.org/presentationml/2006/main">
+  <p:cSld>
+    <p:spTree>
+      <p:nvGrpSpPr>
+        <p:cNvPr id="1" name=""/>
+        <p:cNvGrpSpPr/>
+        <p:nvPr/>
+      </p:nvGrpSpPr>
+      <p:grpSpPr>
+        <a:xfrm>
+          <a:off x="0" y="0"/>
+          <a:ext cx="0" cy="0"/>
+          <a:chOff x="0" y="0"/>
+          <a:chExt cx="0" cy="0"/>
+        </a:xfrm>
+      </p:grpSpPr>
+      <p:sp>
+        <p:nvSpPr>
+          <p:cNvPr id="2" name="Slide Image Placeholder 1"/>
+          <p:cNvSpPr>
+            <a:spLocks noGrp="1" noRot="1" noChangeAspect="1"/>
+          </p:cNvSpPr>
+          <p:nvPr>
+            <p:ph type="sldImg"/>
+          </p:nvPr>
+        </p:nvSpPr>
+        <p:spPr/>
+      </p:sp>
+      <p:sp>
+        <p:nvSpPr>
+          <p:cNvPr id="3" name="Notes Placeholder 2"/>
+          <p:cNvSpPr>
+            <a:spLocks noGrp="1"/>
+          </p:cNvSpPr>
+          <p:nvPr>
+            <p:ph type="body" idx="1"/>
+          </p:nvPr>
+        </p:nvSpPr>
+        <p:spPr/>
+        <p:txBody>
+          <a:bodyPr/>
+          <a:lstStyle/>
+          <a:p>
+            <a:r>
+              <a:t>This slide is a reference table rather than a narrative, and it answers the question a new contributor asks when they are about to write code: am I allowed to touch this path? Read the KIND column first, because it determines the rules — definition files change only through a gated path, and data files accumulate and are never overwritten by an update. The shape that emerges in the top half is a clean division of labor between the plugin skills: setup-openaos writes almost everything but exactly once, build-workflow and refine-workflow each write a single workflow file plus a log entry, and workflow runs write only data. The amber panel spells out the four restricted cases, of which the most consequential is refinement's boundary on governance — it may tune cadence, inputs, output shape, and emphasis, but it may not delete a governance workflow, remove an approval gate, bypass the feedback scrub sequence, or weaken the governance config. The bottom block is the maintainer's side of the line, and no skill and no workflow run writes anywhere in it: content/ and workflow-specs/ are written only by §36.2, design-spec/ only by a Proceed-gated spec edit or by §36.3, and skills/ is the single path where a direct hand-edit is sanctioned — as a drafting surface that §36.3 round-trips back into the spec.</a:t>
+            </a:r>
+          </a:p>
+        </p:txBody>
+      </p:sp>
+      <p:sp>
+        <p:nvSpPr>
+          <p:cNvPr id="4" name="Slide Number Placeholder 3"/>
+          <p:cNvSpPr>
+            <a:spLocks noGrp="1"/>
+          </p:cNvSpPr>
+          <p:nvPr>
+            <p:ph type="sldNum" sz="quarter" idx="5"/>
+          </p:nvPr>
+        </p:nvSpPr>
+        <p:spPr/>
+        <p:txBody>
+          <a:bodyPr/>
+          <a:lstStyle/>
+          <a:p>
+            <a:fld id="{18A5127F-37A6-4871-82C7-A09F5C064F26}" type="slidenum">
+              <a:rPr lang="en-US" smtClean="0"/>
+              <a:t>10</a:t>
+            </a:fld>
+            <a:endParaRPr lang="en-US"/>
+          </a:p>
+        </p:txBody>
+      </p:sp>
+    </p:spTree>
+    <p:extLst>
+      <p:ext uri="{BB962C8B-B14F-4D97-AF65-F5344CB8AC3E}">
+        <p14:creationId xmlns:p14="http://schemas.microsoft.com/office/powerpoint/2010/main" val="1651466609"/>
+      </p:ext>
+    </p:extLst>
+  </p:cSld>
+  <p:clrMapOvr>
+    <a:masterClrMapping/>
+  </p:clrMapOvr>
+</p:notes>
+</file>
+
 <file path=ppt/notesSlides/notesSlide2.xml><?xml version="1.0" encoding="utf-8"?>
 <p:notes xmlns:a="http://schemas.openxmlformats.org/drawingml/2006/main" xmlns:r="http://schemas.openxmlformats.org/officeDocument/2006/relationships" xmlns:p="http://schemas.openxmlformats.org/presentationml/2006/main">
   <p:cSld>
@@ -643,56 +730,24 @@
           <a:lstStyle/>
           <a:p>
             <a:r>
-              <a:rPr lang="en-US" dirty="0"/>
-              <a:t>Three layers, and changes only ever flow downward. The design specification is human-authored and is the single source of truth; the plugin is generated from it and is never hand-edited; the user's workspace is scaffolded by the plugin at install time and thereafter belongs entirely to the user. Two things are worth pausing on. First, the </a:t>
-            </a:r>
-            <a:r>
-              <a:rPr lang="en-US" sz="1300" dirty="0"/>
-              <a:t>content/</a:t>
-            </a:r>
-            <a:r>
-              <a:rPr lang="en-US" dirty="0"/>
-              <a:t> and </a:t>
-            </a:r>
-            <a:r>
-              <a:rPr lang="en-US" sz="1300" dirty="0"/>
-              <a:t>workflow-specs/</a:t>
-            </a:r>
-            <a:r>
-              <a:rPr lang="en-US" dirty="0"/>
-              <a:t> folders are </a:t>
-            </a:r>
-            <a:r>
-              <a:rPr lang="en-US" i="1" dirty="0"/>
-              <a:t>copied</a:t>
-            </a:r>
-            <a:r>
-              <a:rPr lang="en-US" dirty="0"/>
-              <a:t> into the plugin verbatim rather than re-rendered, which is why generation can verify them with a byte-for-byte diff. Second, a single </a:t>
-            </a:r>
-            <a:r>
-              <a:rPr lang="en-US" sz="1300" dirty="0" err="1"/>
+              <a:rPr dirty="0"/>
+              <a:t>Three layers, and changes flow downward at every commit boundary. The design specification is human-authored and is the single source of truth; the plugin is generated from it; the user's workspace is scaffolded by the plugin at install time and thereafter belongs entirely to the user. Three things are worth pausing on. First, the content/ and workflow-specs/ folders are copied into the plugin verbatim rather than re-rendered, which is why generation can verify them with a byte-for-byte diff — and why the same copy can run in reverse during a spec sync. Second, skills/ is the one exception to “never hand-edited”: the plugin copy may be edited directly as a drafting surface, because editing a SKILL.md is concrete in a way that editing §12 of a large specification is not. That edit is not a shortcut into main — runbook §36.3 reflects it back into §8.1/§12/§13, the author reviews and owns the resulting spec prose, and §36.2 then regenerates the skill file from the spec, round-tripping the prototype away. Third, a single </a:t>
+            </a:r>
+            <a:r>
+              <a:rPr dirty="0" err="1"/>
               <a:t>openaos_version</a:t>
             </a:r>
             <a:r>
-              <a:rPr lang="en-US" dirty="0"/>
+              <a:rPr dirty="0"/>
               <a:t> is stamped through all three layers — spec frontmatter, </a:t>
             </a:r>
             <a:r>
-              <a:rPr lang="en-US" sz="1300" dirty="0" err="1"/>
+              <a:rPr dirty="0" err="1"/>
               <a:t>plugin.json</a:t>
             </a:r>
             <a:r>
-              <a:rPr lang="en-US" dirty="0"/>
-              <a:t>, and every generated workspace file — so there is exactly one version fact to reason about rather than a compatibility matrix. The practical consequence for a contributor is that any change to </a:t>
-            </a:r>
-            <a:r>
-              <a:rPr lang="en-US" dirty="0" err="1"/>
-              <a:t>behaviour</a:t>
-            </a:r>
-            <a:r>
-              <a:rPr lang="en-US" dirty="0"/>
-              <a:t> starts at the top of this diagram, never in the middle.</a:t>
+              <a:rPr dirty="0"/>
+              <a:t>, and every generated workspace file — so there is exactly one version fact to reason about rather than a compatibility matrix. The practical consequence for a contributor is unchanged: what you propose is always a change at the top of this diagram.</a:t>
             </a:r>
           </a:p>
         </p:txBody>
@@ -902,7 +957,7 @@
           <a:p>
             <a:r>
               <a:rPr lang="en-US" dirty="0"/>
-              <a:t>The system writes something irreversible in exactly five places, and all five stop at the same gate rather than each inventing its own confirmation style. The gate has a fixed five-part shape drawn from design-spec section §3.1: explain the action, identify the affected files, justify it, state the likely consequence, and ask the user to type the exact word. Anything other than that exact word is a hold — discussion, edits, and even enthusiastic approval of a plan are not Proceed. Two rules are easy to miss and worth stating aloud. Approval is action-specific under §2.5, so a Proceed authorizes one action and does not carry forward to a session or a category. And the feedback workflow inserts a scrub step before its preview, because nothing leaves the user's machine without scrub, preview, and Proceed — that sequence is an important privacy boundary.</a:t>
+              <a:t>The system writes something irreversible in exactly five places, and all five stop at the same gate rather than each inventing its own confirmation style. The gate has a fixed five-part shape drawn from design-spec §3.1: explain the action, identify the affected files, justify it, state the likely consequence, and ask the user to type the exact word. Anything other than that exact word is a hold — discussion, edits, and even enthusiastic approval of a plan are not Proceed. Two rules are easy to miss and worth stating aloud. Approval is action-specific under §2.5, so a Proceed authorizes one action and does not carry forward to a session or a category. And the feedback workflow inserts a scrub step before its preview, because nothing leaves the user's machine without scrub, preview, and Proceed — that sequence is an important privacy boundary.</a:t>
             </a:r>
           </a:p>
         </p:txBody>
@@ -1170,59 +1225,33 @@
           <a:lstStyle/>
           <a:p>
             <a:r>
+              <a:rPr dirty="0"/>
+              <a:t>The design spec and the runbook are peers, not layers. They are both human-authored, neither is generated from the other, and their </a:t>
+            </a:r>
+            <a:r>
               <a:rPr lang="en-US" dirty="0"/>
-              <a:t>The design spec and the runbook are peers, not layers. They are both are human-authored, neither is generated from the other, and their section numbering is deliberately continuous (spec §1–§32, runbook §33–§37) so cross-references resolve in both directions. The division is that the specification says what the system </a:t>
-            </a:r>
-            <a:r>
-              <a:rPr lang="en-US" i="1" dirty="0"/>
-              <a:t>is</a:t>
+              <a:t>§</a:t>
+            </a:r>
+            <a:r>
+              <a:rPr dirty="0"/>
+              <a:t>numbering is deliberately continuous (spec §1–§32, runbook §33–§37) so cross-references resolve in both directions. The division is that the specification says what the system is and the runbook says how to verify it and ship it, which means a change in behavior starts in the spec and a change in procedure starts in the runbook. The middle band is worth reading aloud: every §34 checklist item and every §35 generation source names a specific spec </a:t>
             </a:r>
             <a:r>
               <a:rPr lang="en-US" dirty="0"/>
-              <a:t> and the runbook says how to verify it and ship it, which means a change in behavior starts in the spec and a change in procedure starts in the runbook. The middle band is worth reading aloud: every §34 checklist item and every §35 generation source names a specific spec section, so the runbook never restates the design, it only points at it. The traffic runs the other way too, because which spec sections changed is exactly what decides whether the next review is full or incremental. The bottom strip is the loop where the two documents actually meet, and it contains the detail people get wrong most often: findings from the review become Proceed-gated edits </a:t>
-            </a:r>
-            <a:r>
-              <a:rPr lang="en-US" i="1" dirty="0"/>
-              <a:t>to the spec</a:t>
-            </a:r>
-            <a:r>
-              <a:rPr lang="en-US" dirty="0"/>
-              <a:t>, and the version increments during the review, not during generation. Generation packages a version; it never creates one. One maintenance note when presenting: this diagram hard-codes </a:t>
-            </a:r>
-            <a:r>
-              <a:rPr lang="en-US" sz="1200" kern="1200" dirty="0" err="1">
-                <a:solidFill>
-                  <a:schemeClr val="tx1"/>
-                </a:solidFill>
-                <a:latin typeface="+mn-lt"/>
-                <a:ea typeface="+mn-ea"/>
-                <a:cs typeface="+mn-cs"/>
-              </a:rPr>
+              <a:t>§</a:t>
+            </a:r>
+            <a:r>
+              <a:rPr dirty="0"/>
+              <a:t>or the script that checks it, so the runbook never restates the design, it only points at it. The traffic runs the other way too, because which spec sections changed is exactly what decides whether the next review is full or incremental. The bottom strip is the loop where the two documents actually meet. It now opens with an optional first step: if a plugin file was hand-edited, §36.3 runs before anything else, because the ordering rule in §33 says the two sync directions are never concurrently live. The rest of the strip contains the detail people get wrong most often — findings from the review become Proceed-gated edits to the spec, and the version increments during the review, not during generation. Generation packages a version; it never creates one. One maintenance note when presenting: the stamp band shows </a:t>
+            </a:r>
+            <a:r>
+              <a:rPr dirty="0" err="1"/>
               <a:t>openaos_version</a:t>
             </a:r>
             <a:r>
-              <a:rPr lang="en-US" sz="1200" kern="1200" dirty="0">
-                <a:solidFill>
-                  <a:schemeClr val="tx1"/>
-                </a:solidFill>
-                <a:latin typeface="+mn-lt"/>
-                <a:ea typeface="+mn-ea"/>
-                <a:cs typeface="+mn-cs"/>
-              </a:rPr>
-              <a:t>: 3.1.0 as an example </a:t>
-            </a:r>
-            <a:r>
-              <a:rPr lang="en-US" sz="1200" kern="1200">
-                <a:solidFill>
-                  <a:schemeClr val="tx1"/>
-                </a:solidFill>
-                <a:latin typeface="+mn-lt"/>
-                <a:ea typeface="+mn-ea"/>
-                <a:cs typeface="+mn-cs"/>
-              </a:rPr>
-              <a:t>only.</a:t>
-            </a:r>
-            <a:endParaRPr lang="en-US" dirty="0"/>
+              <a:rPr dirty="0"/>
+              <a:t> 3.2.0 as an illustration of the single version fact, and it will need updating whenever the set is re-stamped.</a:t>
+            </a:r>
           </a:p>
         </p:txBody>
       </p:sp>
@@ -1307,36 +1336,7 @@
           <a:lstStyle/>
           <a:p>
             <a:r>
-              <a:rPr lang="en-US" dirty="0"/>
-              <a:t>This is the maintainer's flow, and it is drawn as one diagram rather than two because the second half cannot start without the first: Runbook §36.2 step 1 is a precondition requiring a completed §36.1 review at the current version. The review runs four mechanical validators — which execute in full regardless of whether the review itself is full or incremental — then verifies the §34 checklist across the whole document set, collects everything onto a single-issue list, and loops until that list is clean, with each remedial spec change itself Proceed-gated. Generation then renders, previews, and validates. The validation list is worth reading closely, because two of its items are structural rather than cosmetic: </a:t>
-            </a:r>
-            <a:r>
-              <a:rPr lang="en-US" sz="1300" dirty="0"/>
-              <a:t>content/</a:t>
-            </a:r>
-            <a:r>
-              <a:rPr lang="en-US" dirty="0"/>
-              <a:t> and </a:t>
-            </a:r>
-            <a:r>
-              <a:rPr lang="en-US" sz="1300" dirty="0"/>
-              <a:t>workflow-specs/</a:t>
-            </a:r>
-            <a:r>
-              <a:rPr lang="en-US" dirty="0"/>
-              <a:t> must be byte-identical to their design-spec sources. That is a deliberate tripwire — hand-editing anything under </a:t>
-            </a:r>
-            <a:r>
-              <a:rPr lang="en-US" sz="1300" dirty="0" err="1"/>
-              <a:t>claude</a:t>
-            </a:r>
-            <a:r>
-              <a:rPr lang="en-US" sz="1300" dirty="0"/>
-              <a:t>-plugin/</a:t>
-            </a:r>
-            <a:r>
-              <a:rPr lang="en-US" dirty="0"/>
-              <a:t> will fail the next generation, and it should. Note also that the version increments during the review, not during generation; generation packages a version, it does not create one.</a:t>
+              <a:t>This is the maintainer's flow, and it is drawn as one diagram rather than two because the second half cannot start without the first: runbook §36.2 step 1 is a precondition requiring a completed §36.1 review at the current version. The review runs six mechanical validators — which execute in full regardless of whether the review itself is full or incremental — then verifies the §34 checklist across the whole document set, collects everything onto one issue list, and loops until that list is clean, with each remedial spec change itself Proceed-gated. An exclusion in sync-exclusions.md whose disposition is still open counts as a finding on that list, so an undecided conflict between a plugin edit and a design tenet does not stop a review from running, only from finalizing. Generation then renders, previews, and validates. Two validation items are structural rather than cosmetic: content/ and workflow-specs/ must be byte-identical to their design-spec sources, and CI asserts the same on every pull request — that is what makes an unreflected plugin edit unable to reach main. skills/ works differently, because it is authored prose with no byte-identity to assert. Before rendering each SKILL.md, generation compares it against the recorded sync baseline; if it has been hand-edited, generation stops and sends you to §36.3 rather than clobbering the edit. Note also that the version increments during the review, not during generation.</a:t>
             </a:r>
           </a:p>
         </p:txBody>
@@ -1401,7 +1401,7 @@
             <a:spLocks noGrp="1" noRot="1" noChangeAspect="1"/>
           </p:cNvSpPr>
           <p:nvPr>
-            <p:ph type="sldImg"/>
+            <p:ph type="sldImg" idx="2"/>
           </p:nvPr>
         </p:nvSpPr>
         <p:spPr/>
@@ -1413,7 +1413,7 @@
             <a:spLocks noGrp="1"/>
           </p:cNvSpPr>
           <p:nvPr>
-            <p:ph type="body" idx="1"/>
+            <p:ph type="body" sz="quarter" idx="3"/>
           </p:nvPr>
         </p:nvSpPr>
         <p:spPr/>
@@ -1423,16 +1423,38 @@
           <a:p>
             <a:r>
               <a:rPr lang="en-US" dirty="0"/>
-              <a:t>This slide is a reference table rather than a narrative, and it answers the question a new contributor asks when they are about to write code: am I allowed to touch this path? Read the KIND column first, because it determines the rules — definition files change only through a gated path, data files accumulate and are never overwritten by an update, and the plugin tree is off-limits to everything except the maintainer-side generation flow. The shape that emerges is a clean division of labor between the plugin skills: /setup-</a:t>
-            </a:r>
-            <a:r>
-              <a:rPr lang="en-US" dirty="0" err="1"/>
-              <a:t>aos</a:t>
-            </a:r>
+              <a:t>This is the path the two-way sync feature added, and it exists for a simple reason: editing a SKILL.md file is quick and easy but editing §12 of the big specification document is not. For the maintainer, that's an annoyance. For an outside contributor, it's a wall that stops them from contributing at all.</a:t>
+            </a:r>
+          </a:p>
+          <a:p>
+            <a:endParaRPr lang="en-US" dirty="0"/>
+          </a:p>
+          <a:p>
             <a:r>
               <a:rPr lang="en-US" dirty="0"/>
-              <a:t> writes almost everything but exactly once, /build-workflow and /refine-workflow each write a single workflow file plus a log entry, and workflow runs write only data. The amber panel spells out the four restricted cases, of which the most consequential is refinement's boundary on governance — it may tune cadence, inputs, output shape, and emphasis, but it may not delete a governance workflow, remove an approval gate, bypass the feedback scrub sequence, or weaken the governance config.</a:t>
-            </a:r>
+              <a:t>§36.3 makes the plugin's copy of a skill an official place to draft changes — but it doesn't create a second path into the main codebase. The rule for submitting changes hasn't changed: you're still proposing a change to the spec, and the plugin code in your pull request must match exactly what the spec would generate. CI checks that automatically.</a:t>
+            </a:r>
+          </a:p>
+          <a:p>
+            <a:endParaRPr lang="en-US" dirty="0"/>
+          </a:p>
+          <a:p>
+            <a:r>
+              <a:rPr lang="en-US" dirty="0"/>
+              <a:t>Two design choices do most of the work here. First, the ordering rule: within each cycle, §36.3 always runs before §36.2, so the two sync directions never run at the same time. That eliminates any question of which side wins, and it's why there's no conflict-resolution logic anywhere in the system.</a:t>
+            </a:r>
+          </a:p>
+          <a:p>
+            <a:endParaRPr lang="en-US" dirty="0"/>
+          </a:p>
+          <a:p>
+            <a:r>
+              <a:rPr lang="en-US" dirty="0"/>
+              <a:t>Second, the tenet gate. Before any change made on the plugin side gets folded back into the spec, it's checked against five principles that already govern the rest of the design: staying in scope, keeping the governance layer non-removable, respecting the boundary between skills and workflows, avoiding drift, and shipping as a single artifact. If a change fails that check, it isn't quietly discarded — it's logged by name, tagged with the principle it violated, added to sync-exclusions.md as unresolved, and it keeps showing up in readiness reviews until someone makes a call on it, even if that call is "leave it as is." This tenet check is intentionally done by a person, not CI, because it requires judgment. CI only handles the mechanical part: confirming the files match exactly.</a:t>
+            </a:r>
+          </a:p>
+          <a:p>
+            <a:endParaRPr dirty="0"/>
           </a:p>
         </p:txBody>
       </p:sp>
@@ -1447,24 +1469,8 @@
           </p:nvPr>
         </p:nvSpPr>
         <p:spPr/>
-        <p:txBody>
-          <a:bodyPr/>
-          <a:lstStyle/>
-          <a:p>
-            <a:fld id="{18A5127F-37A6-4871-82C7-A09F5C064F26}" type="slidenum">
-              <a:rPr lang="en-US" smtClean="0"/>
-              <a:t>9</a:t>
-            </a:fld>
-            <a:endParaRPr lang="en-US"/>
-          </a:p>
-        </p:txBody>
       </p:sp>
     </p:spTree>
-    <p:extLst>
-      <p:ext uri="{BB962C8B-B14F-4D97-AF65-F5344CB8AC3E}">
-        <p14:creationId xmlns:p14="http://schemas.microsoft.com/office/powerpoint/2010/main" val="1651466609"/>
-      </p:ext>
-    </p:extLst>
   </p:cSld>
   <p:clrMapOvr>
     <a:masterClrMapping/>
@@ -1651,7 +1657,7 @@
           <a:p>
             <a:fld id="{5BCAD085-E8A6-8845-BD4E-CB4CCA059FC4}" type="datetimeFigureOut">
               <a:rPr lang="en-US" smtClean="0"/>
-              <a:t>8/4/2026</a:t>
+              <a:t>8/5/2026</a:t>
             </a:fld>
             <a:endParaRPr lang="en-US"/>
           </a:p>
@@ -1819,7 +1825,7 @@
           <a:p>
             <a:fld id="{5BCAD085-E8A6-8845-BD4E-CB4CCA059FC4}" type="datetimeFigureOut">
               <a:rPr lang="en-US" smtClean="0"/>
-              <a:t>8/4/2026</a:t>
+              <a:t>8/5/2026</a:t>
             </a:fld>
             <a:endParaRPr lang="en-US"/>
           </a:p>
@@ -1997,7 +2003,7 @@
           <a:p>
             <a:fld id="{5BCAD085-E8A6-8845-BD4E-CB4CCA059FC4}" type="datetimeFigureOut">
               <a:rPr lang="en-US" smtClean="0"/>
-              <a:t>8/4/2026</a:t>
+              <a:t>8/5/2026</a:t>
             </a:fld>
             <a:endParaRPr lang="en-US"/>
           </a:p>
@@ -2165,7 +2171,7 @@
           <a:p>
             <a:fld id="{5BCAD085-E8A6-8845-BD4E-CB4CCA059FC4}" type="datetimeFigureOut">
               <a:rPr lang="en-US" smtClean="0"/>
-              <a:t>8/4/2026</a:t>
+              <a:t>8/5/2026</a:t>
             </a:fld>
             <a:endParaRPr lang="en-US"/>
           </a:p>
@@ -2410,7 +2416,7 @@
           <a:p>
             <a:fld id="{5BCAD085-E8A6-8845-BD4E-CB4CCA059FC4}" type="datetimeFigureOut">
               <a:rPr lang="en-US" smtClean="0"/>
-              <a:t>8/4/2026</a:t>
+              <a:t>8/5/2026</a:t>
             </a:fld>
             <a:endParaRPr lang="en-US"/>
           </a:p>
@@ -2695,7 +2701,7 @@
           <a:p>
             <a:fld id="{5BCAD085-E8A6-8845-BD4E-CB4CCA059FC4}" type="datetimeFigureOut">
               <a:rPr lang="en-US" smtClean="0"/>
-              <a:t>8/4/2026</a:t>
+              <a:t>8/5/2026</a:t>
             </a:fld>
             <a:endParaRPr lang="en-US"/>
           </a:p>
@@ -3114,7 +3120,7 @@
           <a:p>
             <a:fld id="{5BCAD085-E8A6-8845-BD4E-CB4CCA059FC4}" type="datetimeFigureOut">
               <a:rPr lang="en-US" smtClean="0"/>
-              <a:t>8/4/2026</a:t>
+              <a:t>8/5/2026</a:t>
             </a:fld>
             <a:endParaRPr lang="en-US"/>
           </a:p>
@@ -3231,7 +3237,7 @@
           <a:p>
             <a:fld id="{5BCAD085-E8A6-8845-BD4E-CB4CCA059FC4}" type="datetimeFigureOut">
               <a:rPr lang="en-US" smtClean="0"/>
-              <a:t>8/4/2026</a:t>
+              <a:t>8/5/2026</a:t>
             </a:fld>
             <a:endParaRPr lang="en-US"/>
           </a:p>
@@ -3326,7 +3332,7 @@
           <a:p>
             <a:fld id="{5BCAD085-E8A6-8845-BD4E-CB4CCA059FC4}" type="datetimeFigureOut">
               <a:rPr lang="en-US" smtClean="0"/>
-              <a:t>8/4/2026</a:t>
+              <a:t>8/5/2026</a:t>
             </a:fld>
             <a:endParaRPr lang="en-US"/>
           </a:p>
@@ -3601,7 +3607,7 @@
           <a:p>
             <a:fld id="{5BCAD085-E8A6-8845-BD4E-CB4CCA059FC4}" type="datetimeFigureOut">
               <a:rPr lang="en-US" smtClean="0"/>
-              <a:t>8/4/2026</a:t>
+              <a:t>8/5/2026</a:t>
             </a:fld>
             <a:endParaRPr lang="en-US"/>
           </a:p>
@@ -3853,7 +3859,7 @@
           <a:p>
             <a:fld id="{5BCAD085-E8A6-8845-BD4E-CB4CCA059FC4}" type="datetimeFigureOut">
               <a:rPr lang="en-US" smtClean="0"/>
-              <a:t>8/4/2026</a:t>
+              <a:t>8/5/2026</a:t>
             </a:fld>
             <a:endParaRPr lang="en-US"/>
           </a:p>
@@ -4064,7 +4070,7 @@
           <a:p>
             <a:fld id="{5BCAD085-E8A6-8845-BD4E-CB4CCA059FC4}" type="datetimeFigureOut">
               <a:rPr lang="en-US" smtClean="0"/>
-              <a:t>8/4/2026</a:t>
+              <a:t>8/5/2026</a:t>
             </a:fld>
             <a:endParaRPr lang="en-US"/>
           </a:p>
@@ -4661,6 +4667,202 @@
 </p:sld>
 </file>
 
+<file path=ppt/slides/slide10.xml><?xml version="1.0" encoding="utf-8"?>
+<p:sld xmlns:a="http://schemas.openxmlformats.org/drawingml/2006/main" xmlns:r="http://schemas.openxmlformats.org/officeDocument/2006/relationships" xmlns:p="http://schemas.openxmlformats.org/presentationml/2006/main">
+  <p:cSld>
+    <p:spTree>
+      <p:nvGrpSpPr>
+        <p:cNvPr id="1" name=""/>
+        <p:cNvGrpSpPr/>
+        <p:nvPr/>
+      </p:nvGrpSpPr>
+      <p:grpSpPr>
+        <a:xfrm>
+          <a:off x="0" y="0"/>
+          <a:ext cx="0" cy="0"/>
+          <a:chOff x="0" y="0"/>
+          <a:chExt cx="0" cy="0"/>
+        </a:xfrm>
+      </p:grpSpPr>
+      <p:sp>
+        <p:nvSpPr>
+          <p:cNvPr id="2" name="Rectangle 1"/>
+          <p:cNvSpPr/>
+          <p:nvPr/>
+        </p:nvSpPr>
+        <p:spPr>
+          <a:xfrm>
+            <a:off x="0" y="0"/>
+            <a:ext cx="91440" cy="6858000"/>
+          </a:xfrm>
+          <a:prstGeom prst="rect">
+            <a:avLst/>
+          </a:prstGeom>
+          <a:solidFill>
+            <a:srgbClr val="E2725B"/>
+          </a:solidFill>
+          <a:ln>
+            <a:noFill/>
+          </a:ln>
+          <a:effectLst/>
+        </p:spPr>
+        <p:style>
+          <a:lnRef idx="1">
+            <a:schemeClr val="accent1"/>
+          </a:lnRef>
+          <a:fillRef idx="3">
+            <a:schemeClr val="accent1"/>
+          </a:fillRef>
+          <a:effectRef idx="2">
+            <a:schemeClr val="accent1"/>
+          </a:effectRef>
+          <a:fontRef idx="minor">
+            <a:schemeClr val="lt1"/>
+          </a:fontRef>
+        </p:style>
+        <p:txBody>
+          <a:bodyPr rtlCol="0" anchor="ctr"/>
+          <a:lstStyle/>
+          <a:p>
+            <a:pPr algn="ctr"/>
+            <a:endParaRPr/>
+          </a:p>
+        </p:txBody>
+      </p:sp>
+      <p:sp>
+        <p:nvSpPr>
+          <p:cNvPr id="3" name="TextBox 2"/>
+          <p:cNvSpPr txBox="1"/>
+          <p:nvPr/>
+        </p:nvSpPr>
+        <p:spPr>
+          <a:xfrm>
+            <a:off x="502920" y="274320"/>
+            <a:ext cx="11338560" cy="228600"/>
+          </a:xfrm>
+          <a:prstGeom prst="rect">
+            <a:avLst/>
+          </a:prstGeom>
+          <a:noFill/>
+        </p:spPr>
+        <p:txBody>
+          <a:bodyPr wrap="square" lIns="0" tIns="0" rIns="0" bIns="0">
+            <a:spAutoFit/>
+          </a:bodyPr>
+          <a:lstStyle/>
+          <a:p>
+            <a:r>
+              <a:rPr sz="950" b="1">
+                <a:solidFill>
+                  <a:srgbClr val="E2725B"/>
+                </a:solidFill>
+                <a:latin typeface="Segoe UI"/>
+              </a:rPr>
+              <a:t>ACT 3 · HOW DO I CHANGE IT SAFELY?</a:t>
+            </a:r>
+          </a:p>
+        </p:txBody>
+      </p:sp>
+      <p:sp>
+        <p:nvSpPr>
+          <p:cNvPr id="4" name="TextBox 3"/>
+          <p:cNvSpPr txBox="1"/>
+          <p:nvPr/>
+        </p:nvSpPr>
+        <p:spPr>
+          <a:xfrm>
+            <a:off x="502920" y="502920"/>
+            <a:ext cx="11338560" cy="411480"/>
+          </a:xfrm>
+          <a:prstGeom prst="rect">
+            <a:avLst/>
+          </a:prstGeom>
+          <a:noFill/>
+        </p:spPr>
+        <p:txBody>
+          <a:bodyPr wrap="square" lIns="0" tIns="0" rIns="0" bIns="0">
+            <a:spAutoFit/>
+          </a:bodyPr>
+          <a:lstStyle/>
+          <a:p>
+            <a:r>
+              <a:rPr sz="2200" b="1">
+                <a:solidFill>
+                  <a:srgbClr val="1F2328"/>
+                </a:solidFill>
+                <a:latin typeface="Segoe UI"/>
+              </a:rPr>
+              <a:t>H — Who may write what</a:t>
+            </a:r>
+          </a:p>
+        </p:txBody>
+      </p:sp>
+      <p:sp>
+        <p:nvSpPr>
+          <p:cNvPr id="5" name="TextBox 4"/>
+          <p:cNvSpPr txBox="1"/>
+          <p:nvPr/>
+        </p:nvSpPr>
+        <p:spPr>
+          <a:xfrm>
+            <a:off x="502920" y="932688"/>
+            <a:ext cx="11338560" cy="365760"/>
+          </a:xfrm>
+          <a:prstGeom prst="rect">
+            <a:avLst/>
+          </a:prstGeom>
+          <a:noFill/>
+        </p:spPr>
+        <p:txBody>
+          <a:bodyPr wrap="square" lIns="0" tIns="0" rIns="0" bIns="0">
+            <a:spAutoFit/>
+          </a:bodyPr>
+          <a:lstStyle/>
+          <a:p>
+            <a:r>
+              <a:rPr sz="1200" b="0">
+                <a:solidFill>
+                  <a:srgbClr val="5B6472"/>
+                </a:solidFill>
+                <a:latin typeface="Segoe UI"/>
+              </a:rPr>
+              <a:t>Setup writes almost everything, once. Build and refine write one workflow each. Runs write only data. The runbook writes the rest.</a:t>
+            </a:r>
+          </a:p>
+        </p:txBody>
+      </p:sp>
+      <p:pic>
+        <p:nvPicPr>
+          <p:cNvPr id="6" name="Picture 5" descr="G-ownership-and-write-permissions.png"/>
+          <p:cNvPicPr>
+            <a:picLocks noChangeAspect="1"/>
+          </p:cNvPicPr>
+          <p:nvPr/>
+        </p:nvPicPr>
+        <p:blipFill>
+          <a:blip r:embed="rId3"/>
+          <a:stretch>
+            <a:fillRect/>
+          </a:stretch>
+        </p:blipFill>
+        <p:spPr>
+          <a:xfrm>
+            <a:off x="2897202" y="1417320"/>
+            <a:ext cx="6397595" cy="5166360"/>
+          </a:xfrm>
+          <a:prstGeom prst="rect">
+            <a:avLst/>
+          </a:prstGeom>
+        </p:spPr>
+      </p:pic>
+    </p:spTree>
+  </p:cSld>
+  <p:clrMapOvr>
+    <a:masterClrMapping/>
+  </p:clrMapOvr>
+</p:sld>
+</file>
+
 <file path=ppt/slides/slide2.xml><?xml version="1.0" encoding="utf-8"?>
 <p:sld xmlns:a="http://schemas.openxmlformats.org/drawingml/2006/main" xmlns:r="http://schemas.openxmlformats.org/officeDocument/2006/relationships" xmlns:p="http://schemas.openxmlformats.org/presentationml/2006/main">
   <p:cSld>
@@ -4820,7 +5022,7 @@
                 </a:solidFill>
                 <a:latin typeface="Segoe UI"/>
               </a:rPr>
-              <a:t>Changes flow one way: spec generates the plugin, the plugin scaffolds the workspace. One version fact runs through all three.</a:t>
+              <a:t>Changes flow one way at every commit boundary; the one path back is a drafting aid that round-trips through the spec.</a:t>
             </a:r>
           </a:p>
         </p:txBody>
@@ -4841,8 +5043,8 @@
         </p:blipFill>
         <p:spPr>
           <a:xfrm>
-            <a:off x="2034244" y="1417320"/>
-            <a:ext cx="8123207" cy="5166360"/>
+            <a:off x="2228964" y="1417320"/>
+            <a:ext cx="7734071" cy="5166360"/>
           </a:xfrm>
           <a:prstGeom prst="rect">
             <a:avLst/>
@@ -5839,8 +6041,8 @@
         </p:blipFill>
         <p:spPr>
           <a:xfrm>
-            <a:off x="2384534" y="1417320"/>
-            <a:ext cx="7422931" cy="5166360"/>
+            <a:off x="2930338" y="1417320"/>
+            <a:ext cx="6331323" cy="5166360"/>
           </a:xfrm>
           <a:prstGeom prst="rect">
             <a:avLst/>
@@ -6014,7 +6216,7 @@
                 </a:solidFill>
                 <a:latin typeface="Segoe UI"/>
               </a:rPr>
-              <a:t>Generation cannot start without a clean review at the current version. Spec to plugin is a copy, verified byte-identical.</a:t>
+              <a:t>Generation cannot start without a clean review at the current version — and the baseline guard stops it clobbering an unreflected plugin edit.</a:t>
             </a:r>
           </a:p>
         </p:txBody>
@@ -6035,8 +6237,8 @@
         </p:blipFill>
         <p:spPr>
           <a:xfrm>
-            <a:off x="2234393" y="1417320"/>
-            <a:ext cx="7722909" cy="5166360"/>
+            <a:off x="2824724" y="1417320"/>
+            <a:ext cx="6542551" cy="5166360"/>
           </a:xfrm>
           <a:prstGeom prst="rect">
             <a:avLst/>
@@ -6176,7 +6378,7 @@
                 </a:solidFill>
                 <a:latin typeface="Segoe UI"/>
               </a:rPr>
-              <a:t>H — Who may write what</a:t>
+              <a:t>I — The round trip (§36.3 → §36.2)</a:t>
             </a:r>
           </a:p>
         </p:txBody>
@@ -6210,14 +6412,14 @@
                 </a:solidFill>
                 <a:latin typeface="Segoe UI"/>
               </a:rPr>
-              <a:t>Setup writes almost everything, once. Build and refine write one workflow each. Runs write only data.</a:t>
+              <a:t>A plugin edit can be prototyped, but it round-trips through the spec. The tenet gate decides what may be reflected; CI enforces the rest.</a:t>
             </a:r>
           </a:p>
         </p:txBody>
       </p:sp>
       <p:pic>
         <p:nvPicPr>
-          <p:cNvPr id="6" name="Picture 5" descr="G-ownership-and-write-permissions.png"/>
+          <p:cNvPr id="6" name="Picture 5" descr="I.png"/>
           <p:cNvPicPr>
             <a:picLocks noChangeAspect="1"/>
           </p:cNvPicPr>
@@ -6231,8 +6433,8 @@
         </p:blipFill>
         <p:spPr>
           <a:xfrm>
-            <a:off x="2271587" y="1417320"/>
-            <a:ext cx="7648521" cy="5166360"/>
+            <a:off x="2824724" y="1417320"/>
+            <a:ext cx="6542551" cy="5166360"/>
           </a:xfrm>
           <a:prstGeom prst="rect">
             <a:avLst/>

</xml_diff>